<commit_message>
update the slifes for o11y
Signed-off-by: HungWei Chiu <hwchiu@cloudnative.tw>
</commit_message>
<xml_diff>
--- a/output/part1.pptx
+++ b/output/part1.pptx
@@ -21,8 +21,8 @@
   <p:notesMasterIdLst>
     <p:notesMasterId r:id="rId14"/>
   </p:notesMasterIdLst>
-  <p:sldSz cx="12192000" cy="6858000"/>
-  <p:notesSz cx="6858000" cy="12192000"/>
+  <p:sldSz cx="9144000" cy="5029200"/>
+  <p:notesSz cx="5029200" cy="9144000"/>
   <p:defaultTextStyle>
     <a:lvl1pPr marL="0" algn="l" defTabSz="914400" rtl="0" eaLnBrk="1" latinLnBrk="0" hangingPunct="1">
       <a:defRPr sz="1800" kern="1200">

</xml_diff>

<commit_message>
update slides for o11y and fix ppt format
Signed-off-by: HungWei Chiu <hwchiu@cloudnative.tw>
</commit_message>
<xml_diff>
--- a/output/part1.pptx
+++ b/output/part1.pptx
@@ -2281,7 +2281,7 @@
         <p:spPr>
           <a:xfrm>
             <a:off x="4572000" y="274320"/>
-            <a:ext cx="0" cy="4480560"/>
+            <a:ext cx="9144" cy="4480560"/>
           </a:xfrm>
           <a:prstGeom prst="line">
             <a:avLst/>
@@ -3404,7 +3404,7 @@
         <p:spPr>
           <a:xfrm>
             <a:off x="4572000" y="502920"/>
-            <a:ext cx="0" cy="4434840"/>
+            <a:ext cx="9144" cy="4434840"/>
           </a:xfrm>
           <a:prstGeom prst="line">
             <a:avLst/>
@@ -4809,7 +4809,7 @@
         <p:spPr>
           <a:xfrm>
             <a:off x="5760720" y="1024128"/>
-            <a:ext cx="457200" cy="0"/>
+            <a:ext cx="457200" cy="9144"/>
           </a:xfrm>
           <a:prstGeom prst="line">
             <a:avLst/>
@@ -4935,7 +4935,7 @@
         <p:spPr>
           <a:xfrm>
             <a:off x="5760720" y="1572768"/>
-            <a:ext cx="457200" cy="0"/>
+            <a:ext cx="457200" cy="9144"/>
           </a:xfrm>
           <a:prstGeom prst="line">
             <a:avLst/>
@@ -5061,7 +5061,7 @@
         <p:spPr>
           <a:xfrm>
             <a:off x="5760720" y="2121408"/>
-            <a:ext cx="457200" cy="0"/>
+            <a:ext cx="457200" cy="9144"/>
           </a:xfrm>
           <a:prstGeom prst="line">
             <a:avLst/>
@@ -5758,7 +5758,7 @@
         <p:spPr>
           <a:xfrm>
             <a:off x="4572000" y="502920"/>
-            <a:ext cx="0" cy="4434840"/>
+            <a:ext cx="9144" cy="4434840"/>
           </a:xfrm>
           <a:prstGeom prst="line">
             <a:avLst/>
@@ -5956,7 +5956,7 @@
         <p:spPr>
           <a:xfrm>
             <a:off x="1344168" y="1673352"/>
-            <a:ext cx="365760" cy="0"/>
+            <a:ext cx="365760" cy="9144"/>
           </a:xfrm>
           <a:prstGeom prst="line">
             <a:avLst/>
@@ -6306,8 +6306,8 @@
         </p:nvSpPr>
         <p:spPr>
           <a:xfrm>
-            <a:off x="2587752" y="1298448"/>
-            <a:ext cx="246888" cy="-137160"/>
+            <a:off x="2587752" y="1161288"/>
+            <a:ext cx="246888" cy="137160"/>
           </a:xfrm>
           <a:prstGeom prst="line">
             <a:avLst/>
@@ -6872,7 +6872,7 @@
         <p:spPr>
           <a:xfrm>
             <a:off x="5824728" y="1673352"/>
-            <a:ext cx="365760" cy="0"/>
+            <a:ext cx="365760" cy="9144"/>
           </a:xfrm>
           <a:prstGeom prst="line">
             <a:avLst/>
@@ -7232,8 +7232,8 @@
         </p:nvSpPr>
         <p:spPr>
           <a:xfrm>
-            <a:off x="7068312" y="1353312"/>
-            <a:ext cx="201168" cy="-146304"/>
+            <a:off x="7068312" y="1207008"/>
+            <a:ext cx="201168" cy="146304"/>
           </a:xfrm>
           <a:prstGeom prst="line">
             <a:avLst/>
@@ -7429,7 +7429,7 @@
         <p:spPr>
           <a:xfrm>
             <a:off x="8229600" y="1371600"/>
-            <a:ext cx="0" cy="1188720"/>
+            <a:ext cx="9144" cy="1188720"/>
           </a:xfrm>
           <a:prstGeom prst="line">
             <a:avLst/>
@@ -11054,7 +11054,7 @@
         <p:spPr>
           <a:xfrm>
             <a:off x="1572768" y="1709928"/>
-            <a:ext cx="548640" cy="0"/>
+            <a:ext cx="548640" cy="9144"/>
           </a:xfrm>
           <a:prstGeom prst="line">
             <a:avLst/>
@@ -11355,7 +11355,7 @@
         <p:spPr>
           <a:xfrm>
             <a:off x="4178808" y="1783080"/>
-            <a:ext cx="512064" cy="0"/>
+            <a:ext cx="512064" cy="9144"/>
           </a:xfrm>
           <a:prstGeom prst="line">
             <a:avLst/>
@@ -11566,7 +11566,7 @@
         <p:spPr>
           <a:xfrm>
             <a:off x="6464808" y="1783080"/>
-            <a:ext cx="512064" cy="0"/>
+            <a:ext cx="512064" cy="9144"/>
           </a:xfrm>
           <a:prstGeom prst="line">
             <a:avLst/>
@@ -13256,7 +13256,7 @@
         <p:spPr>
           <a:xfrm>
             <a:off x="1344168" y="1463040"/>
-            <a:ext cx="694944" cy="0"/>
+            <a:ext cx="694944" cy="9144"/>
           </a:xfrm>
           <a:prstGeom prst="line">
             <a:avLst/>
@@ -13319,7 +13319,7 @@
         <p:spPr>
           <a:xfrm>
             <a:off x="3081528" y="1463040"/>
-            <a:ext cx="694944" cy="0"/>
+            <a:ext cx="694944" cy="9144"/>
           </a:xfrm>
           <a:prstGeom prst="line">
             <a:avLst/>
@@ -13382,7 +13382,7 @@
         <p:spPr>
           <a:xfrm>
             <a:off x="4818888" y="1463040"/>
-            <a:ext cx="694944" cy="0"/>
+            <a:ext cx="694944" cy="9144"/>
           </a:xfrm>
           <a:prstGeom prst="line">
             <a:avLst/>
@@ -13445,7 +13445,7 @@
         <p:spPr>
           <a:xfrm>
             <a:off x="6556248" y="1463040"/>
-            <a:ext cx="694944" cy="0"/>
+            <a:ext cx="694944" cy="9144"/>
           </a:xfrm>
           <a:prstGeom prst="line">
             <a:avLst/>
@@ -13508,7 +13508,7 @@
         <p:spPr>
           <a:xfrm>
             <a:off x="1280160" y="2606040"/>
-            <a:ext cx="6035040" cy="0"/>
+            <a:ext cx="6035040" cy="9144"/>
           </a:xfrm>
           <a:prstGeom prst="line">
             <a:avLst/>
@@ -14505,7 +14505,7 @@
         <p:spPr>
           <a:xfrm>
             <a:off x="914400" y="1828800"/>
-            <a:ext cx="502920" cy="0"/>
+            <a:ext cx="502920" cy="9144"/>
           </a:xfrm>
           <a:prstGeom prst="line">
             <a:avLst/>
@@ -14823,7 +14823,7 @@
         <p:spPr>
           <a:xfrm>
             <a:off x="4754880" y="1828800"/>
-            <a:ext cx="822960" cy="0"/>
+            <a:ext cx="822960" cy="9144"/>
           </a:xfrm>
           <a:prstGeom prst="line">
             <a:avLst/>
@@ -16039,7 +16039,7 @@
         <p:spPr>
           <a:xfrm>
             <a:off x="1435608" y="1463040"/>
-            <a:ext cx="420624" cy="0"/>
+            <a:ext cx="420624" cy="9144"/>
           </a:xfrm>
           <a:prstGeom prst="line">
             <a:avLst/>
@@ -16267,7 +16267,7 @@
         <p:spPr>
           <a:xfrm>
             <a:off x="3538728" y="1508760"/>
-            <a:ext cx="457200" cy="0"/>
+            <a:ext cx="457200" cy="9144"/>
           </a:xfrm>
           <a:prstGeom prst="line">
             <a:avLst/>
@@ -16495,7 +16495,7 @@
         <p:spPr>
           <a:xfrm>
             <a:off x="5687568" y="1508760"/>
-            <a:ext cx="457200" cy="0"/>
+            <a:ext cx="457200" cy="9144"/>
           </a:xfrm>
           <a:prstGeom prst="line">
             <a:avLst/>

</xml_diff>